<commit_message>
docs: July-2026 strategy refresh — whole-suite Market Analysis + V12/four-flavors reconciliation
- Add whole-suite Kuja Product & Market Analysis (July 2026), covering
  Marketplace + Grant + ERP, synced to Strategy V3.9 / Deck V12.
- Bump Portfolio Pitch Deck cover label V11 -> V12.
- Reconcile flavor count: Grant Deck V5 + Grant Market Analysis now both
  say FOUR flavors (Closed-Network, Direct-Compliance, Crisis-Context,
  Community-Led SCLR), matching the strategy.
- Mirror all files into docs/Kuja_Portfolio/{00_Overall_Kuja,01_Kuja_Grant}.

Co-Authored-By: Claude Opus 4.8 <noreply@anthropic.com>
</commit_message>
<xml_diff>
--- a/docs/Kuja_Grant_Pitch_Deck_V5_July2026.pptx
+++ b/docs/Kuja_Grant_Pitch_Deck_V5_July2026.pptx
@@ -2919,7 +2919,7 @@
                 <a:ea typeface="Calibri" pitchFamily="34" charset="-122"/>
                 <a:cs typeface="Calibri" pitchFamily="34" charset="-120"/>
               </a:rPr>
-              <a:t>The end-to-end grant system. Three flavors. AI-native. Built BY and FOR the Global South.</a:t>
+              <a:t>The end-to-end grant system. Four flavors. AI-native. Built BY and FOR the Global South.</a:t>
             </a:r>
             <a:endParaRPr lang="en-US" sz="1500" dirty="0"/>
           </a:p>
@@ -24500,7 +24500,7 @@
                 <a:ea typeface="Georgia" pitchFamily="34" charset="-122"/>
                 <a:cs typeface="Georgia" pitchFamily="34" charset="-120"/>
               </a:rPr>
-              <a:t>Three flavors on one codebase</a:t>
+              <a:t>Four flavors on one codebase</a:t>
             </a:r>
             <a:endParaRPr lang="en-US" sz="1400" dirty="0"/>
           </a:p>
@@ -24539,7 +24539,7 @@
                 <a:ea typeface="Calibri" pitchFamily="34" charset="-122"/>
                 <a:cs typeface="Calibri" pitchFamily="34" charset="-120"/>
               </a:rPr>
-              <a:t>Submittable, Foundant, Fluxx are direct-compliance only. None can host a closed network with multi-sig governance — let alone a crisis fund on relational validation. We do all three.</a:t>
+              <a:t>Submittable, Foundant, Fluxx are direct-compliance only. None can host a closed network with multi-sig governance — let alone a crisis fund on relational validation or a community-led fund with no spend policing. We do all four.</a:t>
             </a:r>
             <a:endParaRPr lang="en-US" sz="1050" dirty="0"/>
           </a:p>
@@ -28518,7 +28518,7 @@
                 <a:ea typeface="Calibri" pitchFamily="34" charset="-122"/>
                 <a:cs typeface="Calibri" pitchFamily="34" charset="-120"/>
               </a:rPr>
-              <a:t>Every grant — from either flavor — flows through these five stages. AI grounds every step.</a:t>
+              <a:t>Every grant — from any flavor — flows through these five stages. AI grounds every step.</a:t>
             </a:r>
             <a:endParaRPr lang="en-US" sz="1800" dirty="0"/>
           </a:p>

</xml_diff>